<commit_message>
Deck: team YuvaNex details, no footer, demo video link; add stable demo video file
Co-Authored-By: Claude Opus 5.5 <noreply@anthropic.com>
Claude-Session: https://claude.ai/code/session_01QYwTJ7FubFtFQJrMy2GsyB
</commit_message>
<xml_diff>
--- a/hackathon-submission/Student_Setu_HSC.pptx
+++ b/hackathon-submission/Student_Setu_HSC.pptx
@@ -113,37 +113,37 @@
   <p:extLst>
     <p:ext uri="{521415D9-36F7-43E2-AB2F-B90AF26B5E84}">
       <p14:sectionLst xmlns:p14="http://schemas.microsoft.com/office/powerpoint/2010/main">
-        <p14:section name="Cover" id="{2f6e8c1a-bbfa-b101-4a1f-7b6d31e7ce33}">
+        <p14:section name="Cover" id="{f2fc1904-8771-79f2-d609-87402edeee93}">
           <p14:sldIdLst>
             <p14:sldId id="256"/>
           </p14:sldIdLst>
         </p14:section>
-        <p14:section name="Problem &amp; solution" id="{3c6bc832-607b-073a-a5f4-9d4cbb3e57b3}">
+        <p14:section name="Problem &amp; solution" id="{bac474fe-3d89-01a4-6330-4876ee6edb78}">
           <p14:sldIdLst>
             <p14:sldId id="257"/>
           </p14:sldIdLst>
         </p14:section>
-        <p14:section name="Technical approach" id="{9438f138-0a30-235c-42a7-b325888594f2}">
+        <p14:section name="Technical approach" id="{eeb29cd7-2c3f-5640-c233-0828d190007c}">
           <p14:sldIdLst>
             <p14:sldId id="258"/>
           </p14:sldIdLst>
         </p14:section>
-        <p14:section name="Impact" id="{aa91840a-4249-9539-9cab-be202e8cbe98}">
+        <p14:section name="Impact" id="{8489721f-437f-17d2-af00-bf40105784ce}">
           <p14:sldIdLst>
             <p14:sldId id="259"/>
           </p14:sldIdLst>
         </p14:section>
-        <p14:section name="Feasibility &amp; risk" id="{6a396ac8-960b-936f-10ca-38b0e20a7ede}">
+        <p14:section name="Feasibility &amp; risk" id="{302b8f55-b4a8-8f37-7655-679c42871575}">
           <p14:sldIdLst>
             <p14:sldId id="260"/>
           </p14:sldIdLst>
         </p14:section>
-        <p14:section name="Team" id="{00374367-d867-02b7-5b8c-a8c8bed7d469}">
+        <p14:section name="Team" id="{484b80c4-c015-defb-be0d-cd5cdc06b338}">
           <p14:sldIdLst>
             <p14:sldId id="261"/>
           </p14:sldIdLst>
         </p14:section>
-        <p14:section name="References" id="{328728f5-77d3-9614-9cb0-346d771baa39}">
+        <p14:section name="References" id="{1313c50b-4f06-7b19-c1d7-c560004d349d}">
           <p14:sldIdLst>
             <p14:sldId id="262"/>
           </p14:sldIdLst>
@@ -992,7 +992,7 @@
           <a:p>
             <a:r>
               <a:rPr lang="en-US" dirty="0"/>
-              <a:t>Replace member names and adjust roles. Challenges show the hard problems we solved. Journey: we started as a student-life app and pivoted to learning-first after re-reading the problem statement.</a:t>
+              <a:t>Team YuvaNex: Divyansh Dubey (Team Lead), Khushi Dubey (Frontend), Prakhar Porwal (AI &amp; Backend). Challenges show the hard problems we solved. Journey: we started as a student-life app and pivoted to learning-first after re-reading the problem statement.</a:t>
             </a:r>
             <a:endParaRPr lang="en-US" dirty="0"/>
           </a:p>
@@ -1204,47 +1204,8 @@
         <p:nvSpPr>
           <p:cNvPr id="3" name="Text 0"/>
           <p:cNvSpPr/>
-          <p:nvPr/>
-        </p:nvSpPr>
-        <p:spPr>
-          <a:xfrm>
-            <a:off x="4270248" y="6473952"/>
-            <a:ext cx="3657600" cy="274320"/>
-          </a:xfrm>
-          <a:prstGeom prst="rect">
-            <a:avLst/>
-          </a:prstGeom>
-          <a:noFill/>
-          <a:ln/>
-        </p:spPr>
-        <p:txBody>
-          <a:bodyPr wrap="square" lIns="0" tIns="0" rIns="0" bIns="0" rtlCol="0" anchor="ctr"/>
-          <a:lstStyle/>
-          <a:p>
-            <a:pPr algn="ctr" indent="0" marL="0">
-              <a:buNone/>
-            </a:pPr>
-            <a:r>
-              <a:rPr lang="en-US" sz="1100" dirty="0">
-                <a:solidFill>
-                  <a:srgbClr val="1F3864"/>
-                </a:solidFill>
-                <a:latin typeface="Calibri" pitchFamily="34" charset="0"/>
-                <a:ea typeface="Calibri" pitchFamily="34" charset="-122"/>
-                <a:cs typeface="Calibri" pitchFamily="34" charset="-120"/>
-              </a:rPr>
-              <a:t>@HSC submission</a:t>
-            </a:r>
-            <a:endParaRPr lang="en-US" sz="1100" dirty="0"/>
-          </a:p>
-        </p:txBody>
-      </p:sp>
-      <p:sp>
-        <p:nvSpPr>
-          <p:cNvPr id="4" name="Text 1"/>
-          <p:cNvSpPr/>
           <p:nvPr>
-            <p:ph idx="102" type="title" hasCustomPrompt="1"/>
+            <p:ph idx="101" type="title" hasCustomPrompt="1"/>
           </p:nvPr>
         </p:nvSpPr>
         <p:spPr>
@@ -2669,13 +2630,13 @@
             <a:r>
               <a:rPr lang="en-US" sz="1700" b="1" dirty="0">
                 <a:solidFill>
-                  <a:srgbClr val="F97316"/>
-                </a:solidFill>
-                <a:latin typeface="Calibri" pitchFamily="34" charset="0"/>
-                <a:ea typeface="Calibri" pitchFamily="34" charset="-122"/>
-                <a:cs typeface="Calibri" pitchFamily="34" charset="-120"/>
-              </a:rPr>
-              <a:t>‹Team Name›</a:t>
+                  <a:srgbClr val="1F2A6E"/>
+                </a:solidFill>
+                <a:latin typeface="Calibri" pitchFamily="34" charset="0"/>
+                <a:ea typeface="Calibri" pitchFamily="34" charset="-122"/>
+                <a:cs typeface="Calibri" pitchFamily="34" charset="-120"/>
+              </a:rPr>
+              <a:t>YuvaNex</a:t>
             </a:r>
             <a:endParaRPr lang="en-US" sz="1400" dirty="0"/>
           </a:p>
@@ -2796,13 +2757,13 @@
             <a:r>
               <a:rPr lang="en-US" sz="1700" b="1" dirty="0">
                 <a:solidFill>
-                  <a:srgbClr val="F97316"/>
-                </a:solidFill>
-                <a:latin typeface="Calibri" pitchFamily="34" charset="0"/>
-                <a:ea typeface="Calibri" pitchFamily="34" charset="-122"/>
-                <a:cs typeface="Calibri" pitchFamily="34" charset="-120"/>
-              </a:rPr>
-              <a:t>‹Team ID›</a:t>
+                  <a:srgbClr val="1F2A6E"/>
+                </a:solidFill>
+                <a:latin typeface="Calibri" pitchFamily="34" charset="0"/>
+                <a:ea typeface="Calibri" pitchFamily="34" charset="-122"/>
+                <a:cs typeface="Calibri" pitchFamily="34" charset="-120"/>
+              </a:rPr>
+              <a:t>HSC|MP|00172</a:t>
             </a:r>
             <a:endParaRPr lang="en-US" sz="1400" dirty="0"/>
           </a:p>
@@ -2923,13 +2884,13 @@
             <a:r>
               <a:rPr lang="en-US" sz="1700" b="1" dirty="0">
                 <a:solidFill>
-                  <a:srgbClr val="F97316"/>
-                </a:solidFill>
-                <a:latin typeface="Calibri" pitchFamily="34" charset="0"/>
-                <a:ea typeface="Calibri" pitchFamily="34" charset="-122"/>
-                <a:cs typeface="Calibri" pitchFamily="34" charset="-120"/>
-              </a:rPr>
-              <a:t>‹State / UT›</a:t>
+                  <a:srgbClr val="1F2A6E"/>
+                </a:solidFill>
+                <a:latin typeface="Calibri" pitchFamily="34" charset="0"/>
+                <a:ea typeface="Calibri" pitchFamily="34" charset="-122"/>
+                <a:cs typeface="Calibri" pitchFamily="34" charset="-120"/>
+              </a:rPr>
+              <a:t>Madhya Pradesh</a:t>
             </a:r>
             <a:endParaRPr lang="en-US" sz="1400" dirty="0"/>
           </a:p>
@@ -3027,45 +2988,6 @@
                 <a:cs typeface="Calibri" pitchFamily="34" charset="-120"/>
               </a:rPr>
               <a:t>Scan for live demo</a:t>
-            </a:r>
-            <a:endParaRPr lang="en-US" sz="1100" dirty="0"/>
-          </a:p>
-        </p:txBody>
-      </p:sp>
-      <p:sp>
-        <p:nvSpPr>
-          <p:cNvPr id="41" name="Text 30"/>
-          <p:cNvSpPr txBox="1"/>
-          <p:nvPr/>
-        </p:nvSpPr>
-        <p:spPr>
-          <a:xfrm>
-            <a:off x="6583680" y="6473952"/>
-            <a:ext cx="3657600" cy="274320"/>
-          </a:xfrm>
-          <a:prstGeom prst="rect">
-            <a:avLst/>
-          </a:prstGeom>
-          <a:noFill/>
-          <a:ln/>
-        </p:spPr>
-        <p:txBody>
-          <a:bodyPr wrap="square" lIns="0" tIns="0" rIns="0" bIns="0" rtlCol="0" anchor="t"/>
-          <a:lstStyle/>
-          <a:p>
-            <a:pPr algn="ctr" indent="0" marL="0">
-              <a:buNone/>
-            </a:pPr>
-            <a:r>
-              <a:rPr lang="en-US" sz="1100" dirty="0">
-                <a:solidFill>
-                  <a:srgbClr val="1F3864"/>
-                </a:solidFill>
-                <a:latin typeface="Calibri" pitchFamily="34" charset="0"/>
-                <a:ea typeface="Calibri" pitchFamily="34" charset="-122"/>
-                <a:cs typeface="Calibri" pitchFamily="34" charset="-120"/>
-              </a:rPr>
-              <a:t>@HSC submission</a:t>
             </a:r>
             <a:endParaRPr lang="en-US" sz="1100" dirty="0"/>
           </a:p>
@@ -3098,10 +3020,10 @@
       </p:grpSpPr>
       <p:sp>
         <p:nvSpPr>
-          <p:cNvPr id="2" name="Text 1"/>
+          <p:cNvPr id="2" name="Text 0"/>
           <p:cNvSpPr/>
           <p:nvPr>
-            <p:ph idx="102" type="title" hasCustomPrompt="1"/>
+            <p:ph idx="101" type="title" hasCustomPrompt="1"/>
           </p:nvPr>
         </p:nvSpPr>
         <p:spPr>
@@ -3202,7 +3124,7 @@
                 <a:ea typeface="Calibri" pitchFamily="34" charset="-122"/>
                 <a:cs typeface="Calibri" pitchFamily="34" charset="-120"/>
               </a:rPr>
-              <a:t>‹Team Name›</a:t>
+              <a:t>YuvaNex</a:t>
             </a:r>
             <a:endParaRPr lang="en-US" sz="1300" dirty="0"/>
           </a:p>
@@ -5576,10 +5498,10 @@
       </p:grpSpPr>
       <p:sp>
         <p:nvSpPr>
-          <p:cNvPr id="2" name="Text 1"/>
+          <p:cNvPr id="2" name="Text 0"/>
           <p:cNvSpPr/>
           <p:nvPr>
-            <p:ph idx="102" type="title" hasCustomPrompt="1"/>
+            <p:ph idx="101" type="title" hasCustomPrompt="1"/>
           </p:nvPr>
         </p:nvSpPr>
         <p:spPr>
@@ -5680,7 +5602,7 @@
                 <a:ea typeface="Calibri" pitchFamily="34" charset="-122"/>
                 <a:cs typeface="Calibri" pitchFamily="34" charset="-120"/>
               </a:rPr>
-              <a:t>‹Team Name›</a:t>
+              <a:t>YuvaNex</a:t>
             </a:r>
             <a:endParaRPr lang="en-US" sz="1300" dirty="0"/>
           </a:p>
@@ -8156,7 +8078,9 @@
       </p:sp>
       <p:sp>
         <p:nvSpPr>
-          <p:cNvPr id="81" name="Text 67"/>
+          <p:cNvPr id="81" name="Text 67">
+            <a:hlinkClick r:id="rId15" tooltip=""/>
+          </p:cNvPr>
           <p:cNvSpPr txBox="1"/>
           <p:nvPr/>
         </p:nvSpPr>
@@ -8179,15 +8103,22 @@
               <a:buNone/>
             </a:pPr>
             <a:r>
-              <a:rPr lang="en-US" sz="950" b="1" dirty="0">
-                <a:solidFill>
-                  <a:srgbClr val="F97316"/>
-                </a:solidFill>
-                <a:latin typeface="Calibri" pitchFamily="34" charset="0"/>
-                <a:ea typeface="Calibri" pitchFamily="34" charset="-122"/>
-                <a:cs typeface="Calibri" pitchFamily="34" charset="-120"/>
-              </a:rPr>
-              <a:t>‹Add demo video link›</a:t>
+              <a:rPr lang="en-US" sz="950" u="sng" dirty="0">
+                <a:solidFill>
+                  <a:srgbClr val="4F46E5"/>
+                </a:solidFill>
+                <a:latin typeface="Calibri" pitchFamily="34" charset="0"/>
+                <a:ea typeface="Calibri" pitchFamily="34" charset="-122"/>
+                <a:cs typeface="Calibri" pitchFamily="34" charset="-120"/>
+                <a:hlinkClick r:id="rId15" invalidUrl="" action="" tgtFrame="" tooltip="" history="1" highlightClick="0" endSnd="0">
+                  <a:extLst>
+                    <a:ext uri="{A12FA001-AC4F-418D-AE19-62706E023703}">
+                      <ahyp:hlinkClr xmlns:ahyp="http://schemas.microsoft.com/office/drawing/2018/hyperlinkcolor" val="tx"/>
+                    </a:ext>
+                  </a:extLst>
+                </a:hlinkClick>
+              </a:rPr>
+              <a:t>Watch the 3:45 demo ▶</a:t>
             </a:r>
             <a:endParaRPr lang="en-US" sz="950" dirty="0"/>
           </a:p>
@@ -8254,7 +8185,7 @@
           <p:nvPr/>
         </p:nvPicPr>
         <p:blipFill>
-          <a:blip r:embed="rId15"/>
+          <a:blip r:embed="rId16"/>
           <a:stretch>
             <a:fillRect/>
           </a:stretch>
@@ -8529,10 +8460,10 @@
       </p:grpSpPr>
       <p:sp>
         <p:nvSpPr>
-          <p:cNvPr id="2" name="Text 1"/>
+          <p:cNvPr id="2" name="Text 0"/>
           <p:cNvSpPr/>
           <p:nvPr>
-            <p:ph idx="102" type="title" hasCustomPrompt="1"/>
+            <p:ph idx="101" type="title" hasCustomPrompt="1"/>
           </p:nvPr>
         </p:nvSpPr>
         <p:spPr>
@@ -8633,7 +8564,7 @@
                 <a:ea typeface="Calibri" pitchFamily="34" charset="-122"/>
                 <a:cs typeface="Calibri" pitchFamily="34" charset="-120"/>
               </a:rPr>
-              <a:t>‹Team Name›</a:t>
+              <a:t>YuvaNex</a:t>
             </a:r>
             <a:endParaRPr lang="en-US" sz="1300" dirty="0"/>
           </a:p>
@@ -11211,10 +11142,10 @@
       </p:grpSpPr>
       <p:sp>
         <p:nvSpPr>
-          <p:cNvPr id="2" name="Text 1"/>
+          <p:cNvPr id="2" name="Text 0"/>
           <p:cNvSpPr/>
           <p:nvPr>
-            <p:ph idx="102" type="title" hasCustomPrompt="1"/>
+            <p:ph idx="101" type="title" hasCustomPrompt="1"/>
           </p:nvPr>
         </p:nvSpPr>
         <p:spPr>
@@ -11315,7 +11246,7 @@
                 <a:ea typeface="Calibri" pitchFamily="34" charset="-122"/>
                 <a:cs typeface="Calibri" pitchFamily="34" charset="-120"/>
               </a:rPr>
-              <a:t>‹Team Name›</a:t>
+              <a:t>YuvaNex</a:t>
             </a:r>
             <a:endParaRPr lang="en-US" sz="1300" dirty="0"/>
           </a:p>
@@ -14071,10 +14002,10 @@
       </p:grpSpPr>
       <p:sp>
         <p:nvSpPr>
-          <p:cNvPr id="2" name="Text 1"/>
+          <p:cNvPr id="2" name="Text 0"/>
           <p:cNvSpPr/>
           <p:nvPr>
-            <p:ph idx="102" type="title" hasCustomPrompt="1"/>
+            <p:ph idx="101" type="title" hasCustomPrompt="1"/>
           </p:nvPr>
         </p:nvSpPr>
         <p:spPr>
@@ -14175,7 +14106,7 @@
                 <a:ea typeface="Calibri" pitchFamily="34" charset="-122"/>
                 <a:cs typeface="Calibri" pitchFamily="34" charset="-120"/>
               </a:rPr>
-              <a:t>‹Team Name›</a:t>
+              <a:t>YuvaNex</a:t>
             </a:r>
             <a:endParaRPr lang="en-US" sz="1300" dirty="0"/>
           </a:p>
@@ -14229,11 +14160,11 @@
         <p:spPr>
           <a:xfrm>
             <a:off x="457200" y="1389888"/>
-            <a:ext cx="2697480" cy="1069848"/>
+            <a:ext cx="5486400" cy="694944"/>
           </a:xfrm>
           <a:prstGeom prst="roundRect">
             <a:avLst>
-              <a:gd name="adj" fmla="val 10256"/>
+              <a:gd name="adj" fmla="val 15789"/>
             </a:avLst>
           </a:prstGeom>
           <a:solidFill>
@@ -14262,8 +14193,8 @@
         </p:nvSpPr>
         <p:spPr>
           <a:xfrm>
-            <a:off x="585216" y="1527048"/>
-            <a:ext cx="530352" cy="530352"/>
+            <a:off x="585216" y="1508760"/>
+            <a:ext cx="457200" cy="457200"/>
           </a:xfrm>
           <a:prstGeom prst="ellipse">
             <a:avLst/>
@@ -14295,8 +14226,8 @@
         </p:blipFill>
         <p:spPr>
           <a:xfrm>
-            <a:off x="712500" y="1654332"/>
-            <a:ext cx="275783" cy="275783"/>
+            <a:off x="694944" y="1618488"/>
+            <a:ext cx="237744" cy="237744"/>
           </a:xfrm>
           <a:prstGeom prst="rect">
             <a:avLst/>
@@ -14311,129 +14242,156 @@
         </p:nvSpPr>
         <p:spPr>
           <a:xfrm>
-            <a:off x="1234440" y="1499616"/>
-            <a:ext cx="1828800" cy="274320"/>
-          </a:xfrm>
-          <a:prstGeom prst="rect">
-            <a:avLst/>
-          </a:prstGeom>
-          <a:noFill/>
-          <a:ln/>
-        </p:spPr>
-        <p:txBody>
-          <a:bodyPr wrap="square" lIns="0" tIns="0" rIns="0" bIns="0" rtlCol="0" anchor="t"/>
+            <a:off x="1207008" y="1453896"/>
+            <a:ext cx="2286000" cy="292608"/>
+          </a:xfrm>
+          <a:prstGeom prst="rect">
+            <a:avLst/>
+          </a:prstGeom>
+          <a:noFill/>
+          <a:ln/>
+        </p:spPr>
+        <p:txBody>
+          <a:bodyPr wrap="square" lIns="0" tIns="0" rIns="0" bIns="0" rtlCol="0" anchor="ctr"/>
           <a:lstStyle/>
           <a:p>
             <a:pPr indent="0" marL="0">
               <a:buNone/>
             </a:pPr>
             <a:r>
-              <a:rPr lang="en-US" sz="1300" b="1" dirty="0">
-                <a:solidFill>
-                  <a:srgbClr val="F97316"/>
-                </a:solidFill>
-                <a:latin typeface="Calibri" pitchFamily="34" charset="0"/>
-                <a:ea typeface="Calibri" pitchFamily="34" charset="-122"/>
-                <a:cs typeface="Calibri" pitchFamily="34" charset="-120"/>
-              </a:rPr>
-              <a:t>‹Member 1›</a:t>
-            </a:r>
-            <a:endParaRPr lang="en-US" sz="1300" dirty="0"/>
-          </a:p>
-        </p:txBody>
-      </p:sp>
-      <p:sp>
-        <p:nvSpPr>
-          <p:cNvPr id="10" name="Text 7"/>
-          <p:cNvSpPr txBox="1"/>
-          <p:nvPr/>
-        </p:nvSpPr>
-        <p:spPr>
-          <a:xfrm>
-            <a:off x="1234440" y="1773936"/>
-            <a:ext cx="1828800" cy="256032"/>
-          </a:xfrm>
-          <a:prstGeom prst="rect">
-            <a:avLst/>
-          </a:prstGeom>
-          <a:noFill/>
-          <a:ln/>
-        </p:spPr>
-        <p:txBody>
-          <a:bodyPr wrap="square" lIns="0" tIns="0" rIns="0" bIns="0" rtlCol="0" anchor="t"/>
-          <a:lstStyle/>
-          <a:p>
-            <a:pPr indent="0" marL="0">
-              <a:buNone/>
-            </a:pPr>
-            <a:r>
-              <a:rPr lang="en-US" sz="1100" b="1" dirty="0">
-                <a:solidFill>
-                  <a:srgbClr val="1F2A6E"/>
-                </a:solidFill>
-                <a:latin typeface="Calibri" pitchFamily="34" charset="0"/>
-                <a:ea typeface="Calibri" pitchFamily="34" charset="-122"/>
-                <a:cs typeface="Calibri" pitchFamily="34" charset="-120"/>
-              </a:rPr>
-              <a:t>Team Lead · Full-stack</a:t>
-            </a:r>
-            <a:endParaRPr lang="en-US" sz="1100" dirty="0"/>
-          </a:p>
-        </p:txBody>
-      </p:sp>
-      <p:sp>
-        <p:nvSpPr>
-          <p:cNvPr id="11" name="Text 8"/>
-          <p:cNvSpPr txBox="1"/>
-          <p:nvPr/>
-        </p:nvSpPr>
-        <p:spPr>
-          <a:xfrm>
-            <a:off x="585216" y="2103120"/>
-            <a:ext cx="2487168" cy="310896"/>
-          </a:xfrm>
-          <a:prstGeom prst="rect">
-            <a:avLst/>
-          </a:prstGeom>
-          <a:noFill/>
-          <a:ln/>
-        </p:spPr>
-        <p:txBody>
-          <a:bodyPr wrap="square" lIns="0" tIns="0" rIns="0" bIns="0" rtlCol="0" anchor="t"/>
-          <a:lstStyle/>
-          <a:p>
-            <a:pPr indent="0" marL="0">
-              <a:buNone/>
-            </a:pPr>
-            <a:r>
-              <a:rPr lang="en-US" sz="1000" dirty="0">
-                <a:solidFill>
-                  <a:srgbClr val="64748B"/>
-                </a:solidFill>
-                <a:latin typeface="Calibri" pitchFamily="34" charset="0"/>
-                <a:ea typeface="Calibri" pitchFamily="34" charset="-122"/>
-                <a:cs typeface="Calibri" pitchFamily="34" charset="-120"/>
-              </a:rPr>
-              <a:t>Architecture, serverless functions, deployment</a:t>
-            </a:r>
-            <a:endParaRPr lang="en-US" sz="1000" dirty="0"/>
-          </a:p>
-        </p:txBody>
-      </p:sp>
-      <p:sp>
-        <p:nvSpPr>
-          <p:cNvPr id="12" name="member card"/>
+              <a:rPr lang="en-US" sz="1400" b="1" dirty="0">
+                <a:solidFill>
+                  <a:srgbClr val="0F172A"/>
+                </a:solidFill>
+                <a:latin typeface="Calibri" pitchFamily="34" charset="0"/>
+                <a:ea typeface="Calibri" pitchFamily="34" charset="-122"/>
+                <a:cs typeface="Calibri" pitchFamily="34" charset="-120"/>
+              </a:rPr>
+              <a:t>Divyansh Dubey</a:t>
+            </a:r>
+            <a:endParaRPr lang="en-US" sz="1400" dirty="0"/>
+          </a:p>
+        </p:txBody>
+      </p:sp>
+      <p:sp>
+        <p:nvSpPr>
+          <p:cNvPr id="10" name="role tag"/>
           <p:cNvSpPr/>
           <p:nvPr/>
         </p:nvSpPr>
         <p:spPr>
           <a:xfrm>
-            <a:off x="3273552" y="1389888"/>
-            <a:ext cx="2697480" cy="1069848"/>
+            <a:off x="3611880" y="1481328"/>
+            <a:ext cx="2194560" cy="237744"/>
           </a:xfrm>
           <a:prstGeom prst="roundRect">
             <a:avLst>
-              <a:gd name="adj" fmla="val 10256"/>
+              <a:gd name="adj" fmla="val 50000"/>
+            </a:avLst>
+          </a:prstGeom>
+          <a:solidFill>
+            <a:srgbClr val="1F2A6E"/>
+          </a:solidFill>
+          <a:ln w="12700">
+            <a:solidFill>
+              <a:srgbClr val="1F2A6E"/>
+            </a:solidFill>
+            <a:prstDash val="solid"/>
+          </a:ln>
+        </p:spPr>
+      </p:sp>
+      <p:sp>
+        <p:nvSpPr>
+          <p:cNvPr id="11" name="Text 8"/>
+          <p:cNvSpPr txBox="1"/>
+          <p:nvPr/>
+        </p:nvSpPr>
+        <p:spPr>
+          <a:xfrm>
+            <a:off x="3611880" y="1481328"/>
+            <a:ext cx="2194560" cy="237744"/>
+          </a:xfrm>
+          <a:prstGeom prst="rect">
+            <a:avLst/>
+          </a:prstGeom>
+          <a:noFill/>
+          <a:ln/>
+        </p:spPr>
+        <p:txBody>
+          <a:bodyPr wrap="square" lIns="0" tIns="0" rIns="0" bIns="0" rtlCol="0" anchor="ctr"/>
+          <a:lstStyle/>
+          <a:p>
+            <a:pPr algn="ctr" indent="0" marL="0">
+              <a:buNone/>
+            </a:pPr>
+            <a:r>
+              <a:rPr lang="en-US" sz="1000" b="1" dirty="0">
+                <a:solidFill>
+                  <a:srgbClr val="FFFFFF"/>
+                </a:solidFill>
+                <a:latin typeface="Calibri" pitchFamily="34" charset="0"/>
+                <a:ea typeface="Calibri" pitchFamily="34" charset="-122"/>
+                <a:cs typeface="Calibri" pitchFamily="34" charset="-120"/>
+              </a:rPr>
+              <a:t>Team Lead · Architecture</a:t>
+            </a:r>
+            <a:endParaRPr lang="en-US" sz="1000" dirty="0"/>
+          </a:p>
+        </p:txBody>
+      </p:sp>
+      <p:sp>
+        <p:nvSpPr>
+          <p:cNvPr id="12" name="Text 9"/>
+          <p:cNvSpPr txBox="1"/>
+          <p:nvPr/>
+        </p:nvSpPr>
+        <p:spPr>
+          <a:xfrm>
+            <a:off x="1207008" y="1764792"/>
+            <a:ext cx="4617720" cy="274320"/>
+          </a:xfrm>
+          <a:prstGeom prst="rect">
+            <a:avLst/>
+          </a:prstGeom>
+          <a:noFill/>
+          <a:ln/>
+        </p:spPr>
+        <p:txBody>
+          <a:bodyPr wrap="square" lIns="0" tIns="0" rIns="0" bIns="0" rtlCol="0" anchor="ctr"/>
+          <a:lstStyle/>
+          <a:p>
+            <a:pPr indent="0" marL="0">
+              <a:buNone/>
+            </a:pPr>
+            <a:r>
+              <a:rPr lang="en-US" sz="1050" dirty="0">
+                <a:solidFill>
+                  <a:srgbClr val="334155"/>
+                </a:solidFill>
+                <a:latin typeface="Calibri" pitchFamily="34" charset="0"/>
+                <a:ea typeface="Calibri" pitchFamily="34" charset="-122"/>
+                <a:cs typeface="Calibri" pitchFamily="34" charset="-120"/>
+              </a:rPr>
+              <a:t>Architecture, syllabus–skill mapping, testing, build idea &amp; core concepts</a:t>
+            </a:r>
+            <a:endParaRPr lang="en-US" sz="1050" dirty="0"/>
+          </a:p>
+        </p:txBody>
+      </p:sp>
+      <p:sp>
+        <p:nvSpPr>
+          <p:cNvPr id="13" name="member card"/>
+          <p:cNvSpPr/>
+          <p:nvPr/>
+        </p:nvSpPr>
+        <p:spPr>
+          <a:xfrm>
+            <a:off x="457200" y="2157984"/>
+            <a:ext cx="5486400" cy="694944"/>
+          </a:xfrm>
+          <a:prstGeom prst="roundRect">
+            <a:avLst>
+              <a:gd name="adj" fmla="val 15789"/>
             </a:avLst>
           </a:prstGeom>
           <a:solidFill>
@@ -14456,14 +14414,14 @@
       </p:sp>
       <p:sp>
         <p:nvSpPr>
-          <p:cNvPr id="13" name="Palette circle"/>
+          <p:cNvPr id="14" name="Palette circle"/>
           <p:cNvSpPr/>
           <p:nvPr/>
         </p:nvSpPr>
         <p:spPr>
           <a:xfrm>
-            <a:off x="3401568" y="1527048"/>
-            <a:ext cx="530352" cy="530352"/>
+            <a:off x="585216" y="2276856"/>
+            <a:ext cx="457200" cy="457200"/>
           </a:xfrm>
           <a:prstGeom prst="ellipse">
             <a:avLst/>
@@ -14481,7 +14439,7 @@
       </p:sp>
       <p:pic>
         <p:nvPicPr>
-          <p:cNvPr id="14" name="Palette icon" descr="Palette icon">    </p:cNvPr>
+          <p:cNvPr id="15" name="Palette icon" descr="Palette icon">    </p:cNvPr>
           <p:cNvPicPr>
             <a:picLocks noChangeAspect="1"/>
           </p:cNvPicPr>
@@ -14495,8 +14453,8 @@
         </p:blipFill>
         <p:spPr>
           <a:xfrm>
-            <a:off x="3528852" y="1654332"/>
-            <a:ext cx="275783" cy="275783"/>
+            <a:off x="694944" y="2386584"/>
+            <a:ext cx="237744" cy="237744"/>
           </a:xfrm>
           <a:prstGeom prst="rect">
             <a:avLst/>
@@ -14505,135 +14463,162 @@
       </p:pic>
       <p:sp>
         <p:nvSpPr>
-          <p:cNvPr id="15" name="Text 11"/>
-          <p:cNvSpPr txBox="1"/>
-          <p:nvPr/>
-        </p:nvSpPr>
-        <p:spPr>
-          <a:xfrm>
-            <a:off x="4050792" y="1499616"/>
-            <a:ext cx="1828800" cy="274320"/>
-          </a:xfrm>
-          <a:prstGeom prst="rect">
-            <a:avLst/>
-          </a:prstGeom>
-          <a:noFill/>
-          <a:ln/>
-        </p:spPr>
-        <p:txBody>
-          <a:bodyPr wrap="square" lIns="0" tIns="0" rIns="0" bIns="0" rtlCol="0" anchor="t"/>
+          <p:cNvPr id="16" name="Text 12"/>
+          <p:cNvSpPr txBox="1"/>
+          <p:nvPr/>
+        </p:nvSpPr>
+        <p:spPr>
+          <a:xfrm>
+            <a:off x="1207008" y="2221992"/>
+            <a:ext cx="2286000" cy="292608"/>
+          </a:xfrm>
+          <a:prstGeom prst="rect">
+            <a:avLst/>
+          </a:prstGeom>
+          <a:noFill/>
+          <a:ln/>
+        </p:spPr>
+        <p:txBody>
+          <a:bodyPr wrap="square" lIns="0" tIns="0" rIns="0" bIns="0" rtlCol="0" anchor="ctr"/>
           <a:lstStyle/>
           <a:p>
             <a:pPr indent="0" marL="0">
               <a:buNone/>
             </a:pPr>
             <a:r>
-              <a:rPr lang="en-US" sz="1300" b="1" dirty="0">
-                <a:solidFill>
-                  <a:srgbClr val="F97316"/>
-                </a:solidFill>
-                <a:latin typeface="Calibri" pitchFamily="34" charset="0"/>
-                <a:ea typeface="Calibri" pitchFamily="34" charset="-122"/>
-                <a:cs typeface="Calibri" pitchFamily="34" charset="-120"/>
-              </a:rPr>
-              <a:t>‹Member 2›</a:t>
-            </a:r>
-            <a:endParaRPr lang="en-US" sz="1300" dirty="0"/>
-          </a:p>
-        </p:txBody>
-      </p:sp>
-      <p:sp>
-        <p:nvSpPr>
-          <p:cNvPr id="16" name="Text 12"/>
-          <p:cNvSpPr txBox="1"/>
-          <p:nvPr/>
-        </p:nvSpPr>
-        <p:spPr>
-          <a:xfrm>
-            <a:off x="4050792" y="1773936"/>
-            <a:ext cx="1828800" cy="256032"/>
-          </a:xfrm>
-          <a:prstGeom prst="rect">
-            <a:avLst/>
-          </a:prstGeom>
-          <a:noFill/>
-          <a:ln/>
-        </p:spPr>
-        <p:txBody>
-          <a:bodyPr wrap="square" lIns="0" tIns="0" rIns="0" bIns="0" rtlCol="0" anchor="t"/>
-          <a:lstStyle/>
-          <a:p>
-            <a:pPr indent="0" marL="0">
-              <a:buNone/>
-            </a:pPr>
-            <a:r>
-              <a:rPr lang="en-US" sz="1100" b="1" dirty="0">
-                <a:solidFill>
-                  <a:srgbClr val="F97316"/>
-                </a:solidFill>
-                <a:latin typeface="Calibri" pitchFamily="34" charset="0"/>
-                <a:ea typeface="Calibri" pitchFamily="34" charset="-122"/>
-                <a:cs typeface="Calibri" pitchFamily="34" charset="-120"/>
-              </a:rPr>
-              <a:t>Frontend &amp; UI/UX</a:t>
-            </a:r>
-            <a:endParaRPr lang="en-US" sz="1100" dirty="0"/>
-          </a:p>
-        </p:txBody>
-      </p:sp>
-      <p:sp>
-        <p:nvSpPr>
-          <p:cNvPr id="17" name="Text 13"/>
-          <p:cNvSpPr txBox="1"/>
-          <p:nvPr/>
-        </p:nvSpPr>
-        <p:spPr>
-          <a:xfrm>
-            <a:off x="3401568" y="2103120"/>
-            <a:ext cx="2487168" cy="310896"/>
-          </a:xfrm>
-          <a:prstGeom prst="rect">
-            <a:avLst/>
-          </a:prstGeom>
-          <a:noFill/>
-          <a:ln/>
-        </p:spPr>
-        <p:txBody>
-          <a:bodyPr wrap="square" lIns="0" tIns="0" rIns="0" bIns="0" rtlCol="0" anchor="t"/>
-          <a:lstStyle/>
-          <a:p>
-            <a:pPr indent="0" marL="0">
-              <a:buNone/>
-            </a:pPr>
-            <a:r>
-              <a:rPr lang="en-US" sz="1000" dirty="0">
-                <a:solidFill>
-                  <a:srgbClr val="64748B"/>
-                </a:solidFill>
-                <a:latin typeface="Calibri" pitchFamily="34" charset="0"/>
-                <a:ea typeface="Calibri" pitchFamily="34" charset="-122"/>
-                <a:cs typeface="Calibri" pitchFamily="34" charset="-120"/>
-              </a:rPr>
-              <a:t>React screens, Hindi UI, Lite mode, accessibility</a:t>
-            </a:r>
-            <a:endParaRPr lang="en-US" sz="1000" dirty="0"/>
-          </a:p>
-        </p:txBody>
-      </p:sp>
-      <p:sp>
-        <p:nvSpPr>
-          <p:cNvPr id="18" name="member card"/>
+              <a:rPr lang="en-US" sz="1400" b="1" dirty="0">
+                <a:solidFill>
+                  <a:srgbClr val="0F172A"/>
+                </a:solidFill>
+                <a:latin typeface="Calibri" pitchFamily="34" charset="0"/>
+                <a:ea typeface="Calibri" pitchFamily="34" charset="-122"/>
+                <a:cs typeface="Calibri" pitchFamily="34" charset="-120"/>
+              </a:rPr>
+              <a:t>Khushi Dubey</a:t>
+            </a:r>
+            <a:endParaRPr lang="en-US" sz="1400" dirty="0"/>
+          </a:p>
+        </p:txBody>
+      </p:sp>
+      <p:sp>
+        <p:nvSpPr>
+          <p:cNvPr id="17" name="role tag"/>
           <p:cNvSpPr/>
           <p:nvPr/>
         </p:nvSpPr>
         <p:spPr>
           <a:xfrm>
-            <a:off x="457200" y="2578608"/>
-            <a:ext cx="2697480" cy="1069848"/>
+            <a:off x="3611880" y="2249424"/>
+            <a:ext cx="2194560" cy="237744"/>
           </a:xfrm>
           <a:prstGeom prst="roundRect">
             <a:avLst>
-              <a:gd name="adj" fmla="val 10256"/>
+              <a:gd name="adj" fmla="val 50000"/>
+            </a:avLst>
+          </a:prstGeom>
+          <a:solidFill>
+            <a:srgbClr val="F97316"/>
+          </a:solidFill>
+          <a:ln w="12700">
+            <a:solidFill>
+              <a:srgbClr val="F97316"/>
+            </a:solidFill>
+            <a:prstDash val="solid"/>
+          </a:ln>
+        </p:spPr>
+      </p:sp>
+      <p:sp>
+        <p:nvSpPr>
+          <p:cNvPr id="18" name="Text 14"/>
+          <p:cNvSpPr txBox="1"/>
+          <p:nvPr/>
+        </p:nvSpPr>
+        <p:spPr>
+          <a:xfrm>
+            <a:off x="3611880" y="2249424"/>
+            <a:ext cx="2194560" cy="237744"/>
+          </a:xfrm>
+          <a:prstGeom prst="rect">
+            <a:avLst/>
+          </a:prstGeom>
+          <a:noFill/>
+          <a:ln/>
+        </p:spPr>
+        <p:txBody>
+          <a:bodyPr wrap="square" lIns="0" tIns="0" rIns="0" bIns="0" rtlCol="0" anchor="ctr"/>
+          <a:lstStyle/>
+          <a:p>
+            <a:pPr algn="ctr" indent="0" marL="0">
+              <a:buNone/>
+            </a:pPr>
+            <a:r>
+              <a:rPr lang="en-US" sz="1000" b="1" dirty="0">
+                <a:solidFill>
+                  <a:srgbClr val="FFFFFF"/>
+                </a:solidFill>
+                <a:latin typeface="Calibri" pitchFamily="34" charset="0"/>
+                <a:ea typeface="Calibri" pitchFamily="34" charset="-122"/>
+                <a:cs typeface="Calibri" pitchFamily="34" charset="-120"/>
+              </a:rPr>
+              <a:t>Frontend &amp; UI/UX</a:t>
+            </a:r>
+            <a:endParaRPr lang="en-US" sz="1000" dirty="0"/>
+          </a:p>
+        </p:txBody>
+      </p:sp>
+      <p:sp>
+        <p:nvSpPr>
+          <p:cNvPr id="19" name="Text 15"/>
+          <p:cNvSpPr txBox="1"/>
+          <p:nvPr/>
+        </p:nvSpPr>
+        <p:spPr>
+          <a:xfrm>
+            <a:off x="1207008" y="2532888"/>
+            <a:ext cx="4617720" cy="274320"/>
+          </a:xfrm>
+          <a:prstGeom prst="rect">
+            <a:avLst/>
+          </a:prstGeom>
+          <a:noFill/>
+          <a:ln/>
+        </p:spPr>
+        <p:txBody>
+          <a:bodyPr wrap="square" lIns="0" tIns="0" rIns="0" bIns="0" rtlCol="0" anchor="ctr"/>
+          <a:lstStyle/>
+          <a:p>
+            <a:pPr indent="0" marL="0">
+              <a:buNone/>
+            </a:pPr>
+            <a:r>
+              <a:rPr lang="en-US" sz="1050" dirty="0">
+                <a:solidFill>
+                  <a:srgbClr val="334155"/>
+                </a:solidFill>
+                <a:latin typeface="Calibri" pitchFamily="34" charset="0"/>
+                <a:ea typeface="Calibri" pitchFamily="34" charset="-122"/>
+                <a:cs typeface="Calibri" pitchFamily="34" charset="-120"/>
+              </a:rPr>
+              <a:t>React screens, Hindi UI, Lite mode &amp; accessibility · presenter &amp; speaker</a:t>
+            </a:r>
+            <a:endParaRPr lang="en-US" sz="1050" dirty="0"/>
+          </a:p>
+        </p:txBody>
+      </p:sp>
+      <p:sp>
+        <p:nvSpPr>
+          <p:cNvPr id="20" name="member card"/>
+          <p:cNvSpPr/>
+          <p:nvPr/>
+        </p:nvSpPr>
+        <p:spPr>
+          <a:xfrm>
+            <a:off x="457200" y="2926080"/>
+            <a:ext cx="5486400" cy="694944"/>
+          </a:xfrm>
+          <a:prstGeom prst="roundRect">
+            <a:avLst>
+              <a:gd name="adj" fmla="val 15789"/>
             </a:avLst>
           </a:prstGeom>
           <a:solidFill>
@@ -14656,14 +14641,14 @@
       </p:sp>
       <p:sp>
         <p:nvSpPr>
-          <p:cNvPr id="19" name="Bot circle"/>
+          <p:cNvPr id="21" name="Bot circle"/>
           <p:cNvSpPr/>
           <p:nvPr/>
         </p:nvSpPr>
         <p:spPr>
           <a:xfrm>
-            <a:off x="585216" y="2715768"/>
-            <a:ext cx="530352" cy="530352"/>
+            <a:off x="585216" y="3044952"/>
+            <a:ext cx="457200" cy="457200"/>
           </a:xfrm>
           <a:prstGeom prst="ellipse">
             <a:avLst/>
@@ -14681,7 +14666,7 @@
       </p:sp>
       <p:pic>
         <p:nvPicPr>
-          <p:cNvPr id="20" name="Bot icon" descr="Bot icon">    </p:cNvPr>
+          <p:cNvPr id="22" name="Bot icon" descr="Bot icon">    </p:cNvPr>
           <p:cNvPicPr>
             <a:picLocks noChangeAspect="1"/>
           </p:cNvPicPr>
@@ -14695,8 +14680,8 @@
         </p:blipFill>
         <p:spPr>
           <a:xfrm>
-            <a:off x="712500" y="2843052"/>
-            <a:ext cx="275783" cy="275783"/>
+            <a:off x="694944" y="3154680"/>
+            <a:ext cx="237744" cy="237744"/>
           </a:xfrm>
           <a:prstGeom prst="rect">
             <a:avLst/>
@@ -14705,324 +14690,151 @@
       </p:pic>
       <p:sp>
         <p:nvSpPr>
-          <p:cNvPr id="21" name="Text 16"/>
-          <p:cNvSpPr txBox="1"/>
-          <p:nvPr/>
-        </p:nvSpPr>
-        <p:spPr>
-          <a:xfrm>
-            <a:off x="1234440" y="2688336"/>
-            <a:ext cx="1828800" cy="274320"/>
-          </a:xfrm>
-          <a:prstGeom prst="rect">
-            <a:avLst/>
-          </a:prstGeom>
-          <a:noFill/>
-          <a:ln/>
-        </p:spPr>
-        <p:txBody>
-          <a:bodyPr wrap="square" lIns="0" tIns="0" rIns="0" bIns="0" rtlCol="0" anchor="t"/>
+          <p:cNvPr id="23" name="Text 18"/>
+          <p:cNvSpPr txBox="1"/>
+          <p:nvPr/>
+        </p:nvSpPr>
+        <p:spPr>
+          <a:xfrm>
+            <a:off x="1207008" y="2990088"/>
+            <a:ext cx="2286000" cy="292608"/>
+          </a:xfrm>
+          <a:prstGeom prst="rect">
+            <a:avLst/>
+          </a:prstGeom>
+          <a:noFill/>
+          <a:ln/>
+        </p:spPr>
+        <p:txBody>
+          <a:bodyPr wrap="square" lIns="0" tIns="0" rIns="0" bIns="0" rtlCol="0" anchor="ctr"/>
           <a:lstStyle/>
           <a:p>
             <a:pPr indent="0" marL="0">
               <a:buNone/>
             </a:pPr>
             <a:r>
-              <a:rPr lang="en-US" sz="1300" b="1" dirty="0">
-                <a:solidFill>
-                  <a:srgbClr val="F97316"/>
-                </a:solidFill>
-                <a:latin typeface="Calibri" pitchFamily="34" charset="0"/>
-                <a:ea typeface="Calibri" pitchFamily="34" charset="-122"/>
-                <a:cs typeface="Calibri" pitchFamily="34" charset="-120"/>
-              </a:rPr>
-              <a:t>‹Member 3›</a:t>
-            </a:r>
-            <a:endParaRPr lang="en-US" sz="1300" dirty="0"/>
-          </a:p>
-        </p:txBody>
-      </p:sp>
-      <p:sp>
-        <p:nvSpPr>
-          <p:cNvPr id="22" name="Text 17"/>
-          <p:cNvSpPr txBox="1"/>
-          <p:nvPr/>
-        </p:nvSpPr>
-        <p:spPr>
-          <a:xfrm>
-            <a:off x="1234440" y="2962656"/>
-            <a:ext cx="1828800" cy="256032"/>
-          </a:xfrm>
-          <a:prstGeom prst="rect">
-            <a:avLst/>
-          </a:prstGeom>
-          <a:noFill/>
-          <a:ln/>
-        </p:spPr>
-        <p:txBody>
-          <a:bodyPr wrap="square" lIns="0" tIns="0" rIns="0" bIns="0" rtlCol="0" anchor="t"/>
-          <a:lstStyle/>
-          <a:p>
-            <a:pPr indent="0" marL="0">
-              <a:buNone/>
-            </a:pPr>
-            <a:r>
-              <a:rPr lang="en-US" sz="1100" b="1" dirty="0">
-                <a:solidFill>
-                  <a:srgbClr val="4F46E5"/>
-                </a:solidFill>
-                <a:latin typeface="Calibri" pitchFamily="34" charset="0"/>
-                <a:ea typeface="Calibri" pitchFamily="34" charset="-122"/>
-                <a:cs typeface="Calibri" pitchFamily="34" charset="-120"/>
-              </a:rPr>
-              <a:t>AI &amp; Backend</a:t>
-            </a:r>
-            <a:endParaRPr lang="en-US" sz="1100" dirty="0"/>
-          </a:p>
-        </p:txBody>
-      </p:sp>
-      <p:sp>
-        <p:nvSpPr>
-          <p:cNvPr id="23" name="Text 18"/>
-          <p:cNvSpPr txBox="1"/>
-          <p:nvPr/>
-        </p:nvSpPr>
-        <p:spPr>
-          <a:xfrm>
-            <a:off x="585216" y="3291840"/>
-            <a:ext cx="2487168" cy="310896"/>
-          </a:xfrm>
-          <a:prstGeom prst="rect">
-            <a:avLst/>
-          </a:prstGeom>
-          <a:noFill/>
-          <a:ln/>
-        </p:spPr>
-        <p:txBody>
-          <a:bodyPr wrap="square" lIns="0" tIns="0" rIns="0" bIns="0" rtlCol="0" anchor="t"/>
-          <a:lstStyle/>
-          <a:p>
-            <a:pPr indent="0" marL="0">
-              <a:buNone/>
-            </a:pPr>
-            <a:r>
-              <a:rPr lang="en-US" sz="1000" dirty="0">
-                <a:solidFill>
-                  <a:srgbClr val="64748B"/>
-                </a:solidFill>
-                <a:latin typeface="Calibri" pitchFamily="34" charset="0"/>
-                <a:ea typeface="Calibri" pitchFamily="34" charset="-122"/>
-                <a:cs typeface="Calibri" pitchFamily="34" charset="-120"/>
-              </a:rPr>
-              <a:t>Gemini prompts, quiz grading, signed badges</a:t>
-            </a:r>
-            <a:endParaRPr lang="en-US" sz="1000" dirty="0"/>
-          </a:p>
-        </p:txBody>
-      </p:sp>
-      <p:sp>
-        <p:nvSpPr>
-          <p:cNvPr id="24" name="member card"/>
+              <a:rPr lang="en-US" sz="1400" b="1" dirty="0">
+                <a:solidFill>
+                  <a:srgbClr val="0F172A"/>
+                </a:solidFill>
+                <a:latin typeface="Calibri" pitchFamily="34" charset="0"/>
+                <a:ea typeface="Calibri" pitchFamily="34" charset="-122"/>
+                <a:cs typeface="Calibri" pitchFamily="34" charset="-120"/>
+              </a:rPr>
+              <a:t>Prakhar Porwal</a:t>
+            </a:r>
+            <a:endParaRPr lang="en-US" sz="1400" dirty="0"/>
+          </a:p>
+        </p:txBody>
+      </p:sp>
+      <p:sp>
+        <p:nvSpPr>
+          <p:cNvPr id="24" name="role tag"/>
           <p:cNvSpPr/>
           <p:nvPr/>
         </p:nvSpPr>
         <p:spPr>
           <a:xfrm>
-            <a:off x="3273552" y="2578608"/>
-            <a:ext cx="2697480" cy="1069848"/>
+            <a:off x="3611880" y="3017520"/>
+            <a:ext cx="2194560" cy="237744"/>
           </a:xfrm>
           <a:prstGeom prst="roundRect">
             <a:avLst>
-              <a:gd name="adj" fmla="val 10256"/>
+              <a:gd name="adj" fmla="val 50000"/>
             </a:avLst>
           </a:prstGeom>
           <a:solidFill>
-            <a:srgbClr val="FFFFFF"/>
+            <a:srgbClr val="4F46E5"/>
           </a:solidFill>
-          <a:ln w="9525">
+          <a:ln w="12700">
             <a:solidFill>
-              <a:srgbClr val="E2E8F0"/>
+              <a:srgbClr val="4F46E5"/>
             </a:solidFill>
             <a:prstDash val="solid"/>
           </a:ln>
-          <a:effectLst>
-            <a:outerShdw sx="100000" sy="100000" kx="0" ky="0" algn="bl" rotWithShape="0" blurRad="127000" dist="25400" dir="5400000">
-              <a:srgbClr val="1F2A6E">
-                <a:alpha val="14000"/>
-              </a:srgbClr>
-            </a:outerShdw>
-          </a:effectLst>
-        </p:spPr>
-      </p:sp>
-      <p:sp>
-        <p:nvSpPr>
-          <p:cNvPr id="25" name="Search circle"/>
-          <p:cNvSpPr/>
-          <p:nvPr/>
-        </p:nvSpPr>
-        <p:spPr>
-          <a:xfrm>
-            <a:off x="3401568" y="2715768"/>
-            <a:ext cx="530352" cy="530352"/>
-          </a:xfrm>
-          <a:prstGeom prst="ellipse">
-            <a:avLst/>
-          </a:prstGeom>
-          <a:solidFill>
-            <a:srgbClr val="16A34A"/>
-          </a:solidFill>
-          <a:ln w="12700">
-            <a:solidFill>
-              <a:srgbClr val="16A34A"/>
-            </a:solidFill>
-            <a:prstDash val="solid"/>
-          </a:ln>
-        </p:spPr>
-      </p:sp>
-      <p:pic>
-        <p:nvPicPr>
-          <p:cNvPr id="26" name="Search icon" descr="Search icon">    </p:cNvPr>
-          <p:cNvPicPr>
-            <a:picLocks noChangeAspect="1"/>
-          </p:cNvPicPr>
-          <p:nvPr/>
-        </p:nvPicPr>
-        <p:blipFill>
-          <a:blip r:embed="rId4"/>
-          <a:stretch>
-            <a:fillRect/>
-          </a:stretch>
-        </p:blipFill>
-        <p:spPr>
-          <a:xfrm>
-            <a:off x="3528852" y="2843052"/>
-            <a:ext cx="275783" cy="275783"/>
-          </a:xfrm>
-          <a:prstGeom prst="rect">
-            <a:avLst/>
-          </a:prstGeom>
-        </p:spPr>
-      </p:pic>
-      <p:sp>
-        <p:nvSpPr>
-          <p:cNvPr id="27" name="Text 21"/>
-          <p:cNvSpPr txBox="1"/>
-          <p:nvPr/>
-        </p:nvSpPr>
-        <p:spPr>
-          <a:xfrm>
-            <a:off x="4050792" y="2688336"/>
-            <a:ext cx="1828800" cy="274320"/>
-          </a:xfrm>
-          <a:prstGeom prst="rect">
-            <a:avLst/>
-          </a:prstGeom>
-          <a:noFill/>
-          <a:ln/>
-        </p:spPr>
-        <p:txBody>
-          <a:bodyPr wrap="square" lIns="0" tIns="0" rIns="0" bIns="0" rtlCol="0" anchor="t"/>
+        </p:spPr>
+      </p:sp>
+      <p:sp>
+        <p:nvSpPr>
+          <p:cNvPr id="25" name="Text 20"/>
+          <p:cNvSpPr txBox="1"/>
+          <p:nvPr/>
+        </p:nvSpPr>
+        <p:spPr>
+          <a:xfrm>
+            <a:off x="3611880" y="3017520"/>
+            <a:ext cx="2194560" cy="237744"/>
+          </a:xfrm>
+          <a:prstGeom prst="rect">
+            <a:avLst/>
+          </a:prstGeom>
+          <a:noFill/>
+          <a:ln/>
+        </p:spPr>
+        <p:txBody>
+          <a:bodyPr wrap="square" lIns="0" tIns="0" rIns="0" bIns="0" rtlCol="0" anchor="ctr"/>
+          <a:lstStyle/>
+          <a:p>
+            <a:pPr algn="ctr" indent="0" marL="0">
+              <a:buNone/>
+            </a:pPr>
+            <a:r>
+              <a:rPr lang="en-US" sz="1000" b="1" dirty="0">
+                <a:solidFill>
+                  <a:srgbClr val="FFFFFF"/>
+                </a:solidFill>
+                <a:latin typeface="Calibri" pitchFamily="34" charset="0"/>
+                <a:ea typeface="Calibri" pitchFamily="34" charset="-122"/>
+                <a:cs typeface="Calibri" pitchFamily="34" charset="-120"/>
+              </a:rPr>
+              <a:t>AI &amp; Backend</a:t>
+            </a:r>
+            <a:endParaRPr lang="en-US" sz="1000" dirty="0"/>
+          </a:p>
+        </p:txBody>
+      </p:sp>
+      <p:sp>
+        <p:nvSpPr>
+          <p:cNvPr id="26" name="Text 21"/>
+          <p:cNvSpPr txBox="1"/>
+          <p:nvPr/>
+        </p:nvSpPr>
+        <p:spPr>
+          <a:xfrm>
+            <a:off x="1207008" y="3300984"/>
+            <a:ext cx="4617720" cy="274320"/>
+          </a:xfrm>
+          <a:prstGeom prst="rect">
+            <a:avLst/>
+          </a:prstGeom>
+          <a:noFill/>
+          <a:ln/>
+        </p:spPr>
+        <p:txBody>
+          <a:bodyPr wrap="square" lIns="0" tIns="0" rIns="0" bIns="0" rtlCol="0" anchor="ctr"/>
           <a:lstStyle/>
           <a:p>
             <a:pPr indent="0" marL="0">
               <a:buNone/>
             </a:pPr>
             <a:r>
-              <a:rPr lang="en-US" sz="1300" b="1" dirty="0">
-                <a:solidFill>
-                  <a:srgbClr val="F97316"/>
-                </a:solidFill>
-                <a:latin typeface="Calibri" pitchFamily="34" charset="0"/>
-                <a:ea typeface="Calibri" pitchFamily="34" charset="-122"/>
-                <a:cs typeface="Calibri" pitchFamily="34" charset="-120"/>
-              </a:rPr>
-              <a:t>‹Member 4›</a:t>
-            </a:r>
-            <a:endParaRPr lang="en-US" sz="1300" dirty="0"/>
-          </a:p>
-        </p:txBody>
-      </p:sp>
-      <p:sp>
-        <p:nvSpPr>
-          <p:cNvPr id="28" name="Text 22"/>
-          <p:cNvSpPr txBox="1"/>
-          <p:nvPr/>
-        </p:nvSpPr>
-        <p:spPr>
-          <a:xfrm>
-            <a:off x="4050792" y="2962656"/>
-            <a:ext cx="1828800" cy="256032"/>
-          </a:xfrm>
-          <a:prstGeom prst="rect">
-            <a:avLst/>
-          </a:prstGeom>
-          <a:noFill/>
-          <a:ln/>
-        </p:spPr>
-        <p:txBody>
-          <a:bodyPr wrap="square" lIns="0" tIns="0" rIns="0" bIns="0" rtlCol="0" anchor="t"/>
-          <a:lstStyle/>
-          <a:p>
-            <a:pPr indent="0" marL="0">
-              <a:buNone/>
-            </a:pPr>
-            <a:r>
-              <a:rPr lang="en-US" sz="1100" b="1" dirty="0">
-                <a:solidFill>
-                  <a:srgbClr val="16A34A"/>
-                </a:solidFill>
-                <a:latin typeface="Calibri" pitchFamily="34" charset="0"/>
-                <a:ea typeface="Calibri" pitchFamily="34" charset="-122"/>
-                <a:cs typeface="Calibri" pitchFamily="34" charset="-120"/>
-              </a:rPr>
-              <a:t>Research &amp; Content</a:t>
-            </a:r>
-            <a:endParaRPr lang="en-US" sz="1100" dirty="0"/>
-          </a:p>
-        </p:txBody>
-      </p:sp>
-      <p:sp>
-        <p:nvSpPr>
-          <p:cNvPr id="29" name="Text 23"/>
-          <p:cNvSpPr txBox="1"/>
-          <p:nvPr/>
-        </p:nvSpPr>
-        <p:spPr>
-          <a:xfrm>
-            <a:off x="3401568" y="3291840"/>
-            <a:ext cx="2487168" cy="310896"/>
-          </a:xfrm>
-          <a:prstGeom prst="rect">
-            <a:avLst/>
-          </a:prstGeom>
-          <a:noFill/>
-          <a:ln/>
-        </p:spPr>
-        <p:txBody>
-          <a:bodyPr wrap="square" lIns="0" tIns="0" rIns="0" bIns="0" rtlCol="0" anchor="t"/>
-          <a:lstStyle/>
-          <a:p>
-            <a:pPr indent="0" marL="0">
-              <a:buNone/>
-            </a:pPr>
-            <a:r>
-              <a:rPr lang="en-US" sz="1000" dirty="0">
-                <a:solidFill>
-                  <a:srgbClr val="64748B"/>
-                </a:solidFill>
-                <a:latin typeface="Calibri" pitchFamily="34" charset="0"/>
-                <a:ea typeface="Calibri" pitchFamily="34" charset="-122"/>
-                <a:cs typeface="Calibri" pitchFamily="34" charset="-120"/>
-              </a:rPr>
-              <a:t>Syllabus–skill mapping, vocational modules, testing</a:t>
-            </a:r>
-            <a:endParaRPr lang="en-US" sz="1000" dirty="0"/>
-          </a:p>
-        </p:txBody>
-      </p:sp>
-      <p:sp>
-        <p:nvSpPr>
-          <p:cNvPr id="30" name="Text 24"/>
+              <a:rPr lang="en-US" sz="1050" dirty="0">
+                <a:solidFill>
+                  <a:srgbClr val="334155"/>
+                </a:solidFill>
+                <a:latin typeface="Calibri" pitchFamily="34" charset="0"/>
+                <a:ea typeface="Calibri" pitchFamily="34" charset="-122"/>
+                <a:cs typeface="Calibri" pitchFamily="34" charset="-120"/>
+              </a:rPr>
+              <a:t>Gemini prompts, quiz grading &amp; signed badges</a:t>
+            </a:r>
+            <a:endParaRPr lang="en-US" sz="1050" dirty="0"/>
+          </a:p>
+        </p:txBody>
+      </p:sp>
+      <p:sp>
+        <p:nvSpPr>
+          <p:cNvPr id="27" name="Text 22"/>
           <p:cNvSpPr txBox="1"/>
           <p:nvPr/>
         </p:nvSpPr>
@@ -15061,7 +14873,7 @@
       </p:sp>
       <p:sp>
         <p:nvSpPr>
-          <p:cNvPr id="31" name="KeyRound circle"/>
+          <p:cNvPr id="28" name="KeyRound circle"/>
           <p:cNvSpPr/>
           <p:nvPr/>
         </p:nvSpPr>
@@ -15086,14 +14898,14 @@
       </p:sp>
       <p:pic>
         <p:nvPicPr>
-          <p:cNvPr id="32" name="KeyRound icon" descr="KeyRound icon">    </p:cNvPr>
+          <p:cNvPr id="29" name="KeyRound icon" descr="KeyRound icon">    </p:cNvPr>
           <p:cNvPicPr>
             <a:picLocks noChangeAspect="1"/>
           </p:cNvPicPr>
           <p:nvPr/>
         </p:nvPicPr>
         <p:blipFill>
-          <a:blip r:embed="rId5"/>
+          <a:blip r:embed="rId4"/>
           <a:stretch>
             <a:fillRect/>
           </a:stretch>
@@ -15110,7 +14922,7 @@
       </p:pic>
       <p:sp>
         <p:nvSpPr>
-          <p:cNvPr id="33" name="Text 26"/>
+          <p:cNvPr id="30" name="Text 24"/>
           <p:cNvSpPr txBox="1"/>
           <p:nvPr/>
         </p:nvSpPr>
@@ -15166,7 +14978,7 @@
       </p:sp>
       <p:sp>
         <p:nvSpPr>
-          <p:cNvPr id="34" name="Bot circle"/>
+          <p:cNvPr id="31" name="Bot circle"/>
           <p:cNvSpPr/>
           <p:nvPr/>
         </p:nvSpPr>
@@ -15191,14 +15003,14 @@
       </p:sp>
       <p:pic>
         <p:nvPicPr>
-          <p:cNvPr id="35" name="Bot icon" descr="Bot icon">    </p:cNvPr>
+          <p:cNvPr id="32" name="Bot icon" descr="Bot icon">    </p:cNvPr>
           <p:cNvPicPr>
             <a:picLocks noChangeAspect="1"/>
           </p:cNvPicPr>
           <p:nvPr/>
         </p:nvPicPr>
         <p:blipFill>
-          <a:blip r:embed="rId6"/>
+          <a:blip r:embed="rId5"/>
           <a:stretch>
             <a:fillRect/>
           </a:stretch>
@@ -15215,7 +15027,7 @@
       </p:pic>
       <p:sp>
         <p:nvSpPr>
-          <p:cNvPr id="36" name="Text 28"/>
+          <p:cNvPr id="33" name="Text 26"/>
           <p:cNvSpPr txBox="1"/>
           <p:nvPr/>
         </p:nvSpPr>
@@ -15271,7 +15083,7 @@
       </p:sp>
       <p:sp>
         <p:nvSpPr>
-          <p:cNvPr id="37" name="LifeBuoy circle"/>
+          <p:cNvPr id="34" name="LifeBuoy circle"/>
           <p:cNvSpPr/>
           <p:nvPr/>
         </p:nvSpPr>
@@ -15296,14 +15108,14 @@
       </p:sp>
       <p:pic>
         <p:nvPicPr>
-          <p:cNvPr id="38" name="LifeBuoy icon" descr="LifeBuoy icon">    </p:cNvPr>
+          <p:cNvPr id="35" name="LifeBuoy icon" descr="LifeBuoy icon">    </p:cNvPr>
           <p:cNvPicPr>
             <a:picLocks noChangeAspect="1"/>
           </p:cNvPicPr>
           <p:nvPr/>
         </p:nvPicPr>
         <p:blipFill>
-          <a:blip r:embed="rId7"/>
+          <a:blip r:embed="rId6"/>
           <a:stretch>
             <a:fillRect/>
           </a:stretch>
@@ -15320,7 +15132,7 @@
       </p:pic>
       <p:sp>
         <p:nvSpPr>
-          <p:cNvPr id="39" name="Text 30"/>
+          <p:cNvPr id="36" name="Text 28"/>
           <p:cNvSpPr txBox="1"/>
           <p:nvPr/>
         </p:nvSpPr>
@@ -15376,7 +15188,7 @@
       </p:sp>
       <p:sp>
         <p:nvSpPr>
-          <p:cNvPr id="40" name="Route circle"/>
+          <p:cNvPr id="37" name="Route circle"/>
           <p:cNvSpPr/>
           <p:nvPr/>
         </p:nvSpPr>
@@ -15401,14 +15213,14 @@
       </p:sp>
       <p:pic>
         <p:nvPicPr>
-          <p:cNvPr id="41" name="Route icon" descr="Route icon">    </p:cNvPr>
+          <p:cNvPr id="38" name="Route icon" descr="Route icon">    </p:cNvPr>
           <p:cNvPicPr>
             <a:picLocks noChangeAspect="1"/>
           </p:cNvPicPr>
           <p:nvPr/>
         </p:nvPicPr>
         <p:blipFill>
-          <a:blip r:embed="rId8"/>
+          <a:blip r:embed="rId7"/>
           <a:stretch>
             <a:fillRect/>
           </a:stretch>
@@ -15425,7 +15237,7 @@
       </p:pic>
       <p:sp>
         <p:nvSpPr>
-          <p:cNvPr id="42" name="Text 32"/>
+          <p:cNvPr id="39" name="Text 30"/>
           <p:cNvSpPr txBox="1"/>
           <p:nvPr/>
         </p:nvSpPr>
@@ -15481,7 +15293,7 @@
       </p:sp>
       <p:sp>
         <p:nvSpPr>
-          <p:cNvPr id="43" name="UserCheck circle"/>
+          <p:cNvPr id="40" name="UserCheck circle"/>
           <p:cNvSpPr/>
           <p:nvPr/>
         </p:nvSpPr>
@@ -15506,14 +15318,14 @@
       </p:sp>
       <p:pic>
         <p:nvPicPr>
-          <p:cNvPr id="44" name="UserCheck icon" descr="UserCheck icon">    </p:cNvPr>
+          <p:cNvPr id="41" name="UserCheck icon" descr="UserCheck icon">    </p:cNvPr>
           <p:cNvPicPr>
             <a:picLocks noChangeAspect="1"/>
           </p:cNvPicPr>
           <p:nvPr/>
         </p:nvPicPr>
         <p:blipFill>
-          <a:blip r:embed="rId9"/>
+          <a:blip r:embed="rId8"/>
           <a:stretch>
             <a:fillRect/>
           </a:stretch>
@@ -15530,7 +15342,7 @@
       </p:pic>
       <p:sp>
         <p:nvSpPr>
-          <p:cNvPr id="45" name="Text 34"/>
+          <p:cNvPr id="42" name="Text 32"/>
           <p:cNvSpPr txBox="1"/>
           <p:nvPr/>
         </p:nvSpPr>
@@ -15586,7 +15398,7 @@
       </p:sp>
       <p:sp>
         <p:nvSpPr>
-          <p:cNvPr id="46" name="Text 35"/>
+          <p:cNvPr id="43" name="Text 33"/>
           <p:cNvSpPr txBox="1"/>
           <p:nvPr/>
         </p:nvSpPr>
@@ -15625,7 +15437,7 @@
       </p:sp>
       <p:sp>
         <p:nvSpPr>
-          <p:cNvPr id="47" name="timeline"/>
+          <p:cNvPr id="44" name="timeline"/>
           <p:cNvSpPr/>
           <p:nvPr/>
         </p:nvSpPr>
@@ -15648,7 +15460,7 @@
       </p:sp>
       <p:sp>
         <p:nvSpPr>
-          <p:cNvPr id="48" name="milestone"/>
+          <p:cNvPr id="45" name="milestone"/>
           <p:cNvSpPr/>
           <p:nvPr/>
         </p:nvSpPr>
@@ -15673,7 +15485,7 @@
       </p:sp>
       <p:sp>
         <p:nvSpPr>
-          <p:cNvPr id="49" name="Text 38"/>
+          <p:cNvPr id="46" name="Text 36"/>
           <p:cNvSpPr txBox="1"/>
           <p:nvPr/>
         </p:nvSpPr>
@@ -15712,7 +15524,7 @@
       </p:sp>
       <p:sp>
         <p:nvSpPr>
-          <p:cNvPr id="50" name="journey card"/>
+          <p:cNvPr id="47" name="journey card"/>
           <p:cNvSpPr/>
           <p:nvPr/>
         </p:nvSpPr>
@@ -15739,7 +15551,7 @@
       </p:sp>
       <p:sp>
         <p:nvSpPr>
-          <p:cNvPr id="51" name="Text 40"/>
+          <p:cNvPr id="48" name="Text 38"/>
           <p:cNvSpPr txBox="1"/>
           <p:nvPr/>
         </p:nvSpPr>
@@ -15778,7 +15590,7 @@
       </p:sp>
       <p:sp>
         <p:nvSpPr>
-          <p:cNvPr id="52" name="Text 41"/>
+          <p:cNvPr id="49" name="Text 39"/>
           <p:cNvSpPr txBox="1"/>
           <p:nvPr/>
         </p:nvSpPr>
@@ -15817,7 +15629,7 @@
       </p:sp>
       <p:sp>
         <p:nvSpPr>
-          <p:cNvPr id="53" name="milestone"/>
+          <p:cNvPr id="50" name="milestone"/>
           <p:cNvSpPr/>
           <p:nvPr/>
         </p:nvSpPr>
@@ -15842,7 +15654,7 @@
       </p:sp>
       <p:sp>
         <p:nvSpPr>
-          <p:cNvPr id="54" name="Text 43"/>
+          <p:cNvPr id="51" name="Text 41"/>
           <p:cNvSpPr txBox="1"/>
           <p:nvPr/>
         </p:nvSpPr>
@@ -15881,7 +15693,7 @@
       </p:sp>
       <p:sp>
         <p:nvSpPr>
-          <p:cNvPr id="55" name="journey card"/>
+          <p:cNvPr id="52" name="journey card"/>
           <p:cNvSpPr/>
           <p:nvPr/>
         </p:nvSpPr>
@@ -15908,7 +15720,7 @@
       </p:sp>
       <p:sp>
         <p:nvSpPr>
-          <p:cNvPr id="56" name="Text 45"/>
+          <p:cNvPr id="53" name="Text 43"/>
           <p:cNvSpPr txBox="1"/>
           <p:nvPr/>
         </p:nvSpPr>
@@ -15947,7 +15759,7 @@
       </p:sp>
       <p:sp>
         <p:nvSpPr>
-          <p:cNvPr id="57" name="Text 46"/>
+          <p:cNvPr id="54" name="Text 44"/>
           <p:cNvSpPr txBox="1"/>
           <p:nvPr/>
         </p:nvSpPr>
@@ -15986,7 +15798,7 @@
       </p:sp>
       <p:sp>
         <p:nvSpPr>
-          <p:cNvPr id="58" name="milestone"/>
+          <p:cNvPr id="55" name="milestone"/>
           <p:cNvSpPr/>
           <p:nvPr/>
         </p:nvSpPr>
@@ -16011,7 +15823,7 @@
       </p:sp>
       <p:sp>
         <p:nvSpPr>
-          <p:cNvPr id="59" name="Text 48"/>
+          <p:cNvPr id="56" name="Text 46"/>
           <p:cNvSpPr txBox="1"/>
           <p:nvPr/>
         </p:nvSpPr>
@@ -16050,7 +15862,7 @@
       </p:sp>
       <p:sp>
         <p:nvSpPr>
-          <p:cNvPr id="60" name="journey card"/>
+          <p:cNvPr id="57" name="journey card"/>
           <p:cNvSpPr/>
           <p:nvPr/>
         </p:nvSpPr>
@@ -16077,7 +15889,7 @@
       </p:sp>
       <p:sp>
         <p:nvSpPr>
-          <p:cNvPr id="61" name="Text 50"/>
+          <p:cNvPr id="58" name="Text 48"/>
           <p:cNvSpPr txBox="1"/>
           <p:nvPr/>
         </p:nvSpPr>
@@ -16116,7 +15928,7 @@
       </p:sp>
       <p:sp>
         <p:nvSpPr>
-          <p:cNvPr id="62" name="Text 51"/>
+          <p:cNvPr id="59" name="Text 49"/>
           <p:cNvSpPr txBox="1"/>
           <p:nvPr/>
         </p:nvSpPr>
@@ -16155,7 +15967,7 @@
       </p:sp>
       <p:sp>
         <p:nvSpPr>
-          <p:cNvPr id="63" name="milestone"/>
+          <p:cNvPr id="60" name="milestone"/>
           <p:cNvSpPr/>
           <p:nvPr/>
         </p:nvSpPr>
@@ -16180,7 +15992,7 @@
       </p:sp>
       <p:sp>
         <p:nvSpPr>
-          <p:cNvPr id="64" name="Text 53"/>
+          <p:cNvPr id="61" name="Text 51"/>
           <p:cNvSpPr txBox="1"/>
           <p:nvPr/>
         </p:nvSpPr>
@@ -16219,7 +16031,7 @@
       </p:sp>
       <p:sp>
         <p:nvSpPr>
-          <p:cNvPr id="65" name="journey card"/>
+          <p:cNvPr id="62" name="journey card"/>
           <p:cNvSpPr/>
           <p:nvPr/>
         </p:nvSpPr>
@@ -16246,7 +16058,7 @@
       </p:sp>
       <p:sp>
         <p:nvSpPr>
-          <p:cNvPr id="66" name="Text 55"/>
+          <p:cNvPr id="63" name="Text 53"/>
           <p:cNvSpPr txBox="1"/>
           <p:nvPr/>
         </p:nvSpPr>
@@ -16285,7 +16097,7 @@
       </p:sp>
       <p:sp>
         <p:nvSpPr>
-          <p:cNvPr id="67" name="Text 56"/>
+          <p:cNvPr id="64" name="Text 54"/>
           <p:cNvSpPr txBox="1"/>
           <p:nvPr/>
         </p:nvSpPr>
@@ -16324,7 +16136,7 @@
       </p:sp>
       <p:sp>
         <p:nvSpPr>
-          <p:cNvPr id="68" name="milestone"/>
+          <p:cNvPr id="65" name="milestone"/>
           <p:cNvSpPr/>
           <p:nvPr/>
         </p:nvSpPr>
@@ -16349,7 +16161,7 @@
       </p:sp>
       <p:sp>
         <p:nvSpPr>
-          <p:cNvPr id="69" name="Text 58"/>
+          <p:cNvPr id="66" name="Text 56"/>
           <p:cNvSpPr txBox="1"/>
           <p:nvPr/>
         </p:nvSpPr>
@@ -16388,7 +16200,7 @@
       </p:sp>
       <p:sp>
         <p:nvSpPr>
-          <p:cNvPr id="70" name="journey card"/>
+          <p:cNvPr id="67" name="journey card"/>
           <p:cNvSpPr/>
           <p:nvPr/>
         </p:nvSpPr>
@@ -16415,7 +16227,7 @@
       </p:sp>
       <p:sp>
         <p:nvSpPr>
-          <p:cNvPr id="71" name="Text 60"/>
+          <p:cNvPr id="68" name="Text 58"/>
           <p:cNvSpPr txBox="1"/>
           <p:nvPr/>
         </p:nvSpPr>
@@ -16454,7 +16266,7 @@
       </p:sp>
       <p:sp>
         <p:nvSpPr>
-          <p:cNvPr id="72" name="Text 61"/>
+          <p:cNvPr id="69" name="Text 59"/>
           <p:cNvSpPr txBox="1"/>
           <p:nvPr/>
         </p:nvSpPr>
@@ -16493,7 +16305,7 @@
       </p:sp>
       <p:sp>
         <p:nvSpPr>
-          <p:cNvPr id="73" name="milestone"/>
+          <p:cNvPr id="70" name="milestone"/>
           <p:cNvSpPr/>
           <p:nvPr/>
         </p:nvSpPr>
@@ -16518,7 +16330,7 @@
       </p:sp>
       <p:sp>
         <p:nvSpPr>
-          <p:cNvPr id="74" name="Text 63"/>
+          <p:cNvPr id="71" name="Text 61"/>
           <p:cNvSpPr txBox="1"/>
           <p:nvPr/>
         </p:nvSpPr>
@@ -16557,7 +16369,7 @@
       </p:sp>
       <p:sp>
         <p:nvSpPr>
-          <p:cNvPr id="75" name="journey card"/>
+          <p:cNvPr id="72" name="journey card"/>
           <p:cNvSpPr/>
           <p:nvPr/>
         </p:nvSpPr>
@@ -16584,7 +16396,7 @@
       </p:sp>
       <p:sp>
         <p:nvSpPr>
-          <p:cNvPr id="76" name="Text 65"/>
+          <p:cNvPr id="73" name="Text 63"/>
           <p:cNvSpPr txBox="1"/>
           <p:nvPr/>
         </p:nvSpPr>
@@ -16623,7 +16435,7 @@
       </p:sp>
       <p:sp>
         <p:nvSpPr>
-          <p:cNvPr id="77" name="Text 66"/>
+          <p:cNvPr id="74" name="Text 64"/>
           <p:cNvSpPr txBox="1"/>
           <p:nvPr/>
         </p:nvSpPr>
@@ -16735,10 +16547,10 @@
       </p:grpSpPr>
       <p:sp>
         <p:nvSpPr>
-          <p:cNvPr id="2" name="Text 1"/>
+          <p:cNvPr id="2" name="Text 0"/>
           <p:cNvSpPr/>
           <p:nvPr>
-            <p:ph idx="102" type="title" hasCustomPrompt="1"/>
+            <p:ph idx="101" type="title" hasCustomPrompt="1"/>
           </p:nvPr>
         </p:nvSpPr>
         <p:spPr>
@@ -16839,7 +16651,7 @@
                 <a:ea typeface="Calibri" pitchFamily="34" charset="-122"/>
                 <a:cs typeface="Calibri" pitchFamily="34" charset="-120"/>
               </a:rPr>
-              <a:t>‹Team Name›</a:t>
+              <a:t>YuvaNex</a:t>
             </a:r>
             <a:endParaRPr lang="en-US" sz="1300" dirty="0"/>
           </a:p>
@@ -18448,7 +18260,7 @@
         <p:spPr>
           <a:xfrm>
             <a:off x="1024128" y="5468112"/>
-            <a:ext cx="6858000" cy="246888"/>
+            <a:ext cx="6126480" cy="246888"/>
           </a:xfrm>
           <a:prstGeom prst="rect">
             <a:avLst/>
@@ -18532,7 +18344,7 @@
         <p:spPr>
           <a:xfrm>
             <a:off x="1024128" y="5733288"/>
-            <a:ext cx="6858000" cy="246888"/>
+            <a:ext cx="6126480" cy="246888"/>
           </a:xfrm>
           <a:prstGeom prst="rect">
             <a:avLst/>
@@ -18616,7 +18428,7 @@
         <p:spPr>
           <a:xfrm>
             <a:off x="1024128" y="5998464"/>
-            <a:ext cx="6858000" cy="246888"/>
+            <a:ext cx="6126480" cy="246888"/>
           </a:xfrm>
           <a:prstGeom prst="rect">
             <a:avLst/>
@@ -18646,15 +18458,22 @@
               <a:buNone/>
             </a:pPr>
             <a:r>
-              <a:rPr lang="en-US" sz="1150" dirty="0">
+              <a:rPr lang="en-US" sz="1150" u="sng" dirty="0">
                 <a:solidFill>
                   <a:srgbClr val="FFFFFF"/>
                 </a:solidFill>
                 <a:latin typeface="Calibri" pitchFamily="34" charset="0"/>
                 <a:ea typeface="Calibri" pitchFamily="34" charset="-122"/>
                 <a:cs typeface="Calibri" pitchFamily="34" charset="-120"/>
-              </a:rPr>
-              <a:t>‹Add demo video link›</a:t>
+                <a:hlinkClick r:id="rId22" invalidUrl="" action="" tgtFrame="" tooltip="" history="1" highlightClick="0" endSnd="0">
+                  <a:extLst>
+                    <a:ext uri="{A12FA001-AC4F-418D-AE19-62706E023703}">
+                      <ahyp:hlinkClr xmlns:ahyp="http://schemas.microsoft.com/office/drawing/2018/hyperlinkcolor" val="tx"/>
+                    </a:ext>
+                  </a:extLst>
+                </a:hlinkClick>
+              </a:rPr>
+              <a:t>Student_Setu_Demo_Video.mp4 (GitHub)</a:t>
             </a:r>
             <a:endParaRPr lang="en-US" sz="1150" dirty="0"/>
           </a:p>
@@ -18662,70 +18481,7 @@
       </p:sp>
       <p:pic>
         <p:nvPicPr>
-          <p:cNvPr id="51" name="qr Live demo" descr="QR code: Live demo">    </p:cNvPr>
-          <p:cNvPicPr>
-            <a:picLocks noChangeAspect="1"/>
-          </p:cNvPicPr>
-          <p:nvPr/>
-        </p:nvPicPr>
-        <p:blipFill>
-          <a:blip r:embed="rId22"/>
-          <a:stretch>
-            <a:fillRect/>
-          </a:stretch>
-        </p:blipFill>
-        <p:spPr>
-          <a:xfrm>
-            <a:off x="8778240" y="5029200"/>
-            <a:ext cx="914400" cy="914400"/>
-          </a:xfrm>
-          <a:prstGeom prst="rect">
-            <a:avLst/>
-          </a:prstGeom>
-        </p:spPr>
-      </p:pic>
-      <p:sp>
-        <p:nvSpPr>
-          <p:cNvPr id="52" name="Text 43"/>
-          <p:cNvSpPr txBox="1"/>
-          <p:nvPr/>
-        </p:nvSpPr>
-        <p:spPr>
-          <a:xfrm>
-            <a:off x="8595360" y="5971032"/>
-            <a:ext cx="1280160" cy="228600"/>
-          </a:xfrm>
-          <a:prstGeom prst="rect">
-            <a:avLst/>
-          </a:prstGeom>
-          <a:noFill/>
-          <a:ln/>
-        </p:spPr>
-        <p:txBody>
-          <a:bodyPr wrap="square" lIns="0" tIns="0" rIns="0" bIns="0" rtlCol="0" anchor="t"/>
-          <a:lstStyle/>
-          <a:p>
-            <a:pPr algn="ctr" indent="0" marL="0">
-              <a:buNone/>
-            </a:pPr>
-            <a:r>
-              <a:rPr lang="en-US" sz="1050" b="1" dirty="0">
-                <a:solidFill>
-                  <a:srgbClr val="FFFFFF"/>
-                </a:solidFill>
-                <a:latin typeface="Calibri" pitchFamily="34" charset="0"/>
-                <a:ea typeface="Calibri" pitchFamily="34" charset="-122"/>
-                <a:cs typeface="Calibri" pitchFamily="34" charset="-120"/>
-              </a:rPr>
-              <a:t>Live demo</a:t>
-            </a:r>
-            <a:endParaRPr lang="en-US" sz="1050" dirty="0"/>
-          </a:p>
-        </p:txBody>
-      </p:sp>
-      <p:pic>
-        <p:nvPicPr>
-          <p:cNvPr id="53" name="qr GitHub" descr="QR code: GitHub">    </p:cNvPr>
+          <p:cNvPr id="51" name="qr Demo video" descr="QR code: Demo video">    </p:cNvPr>
           <p:cNvPicPr>
             <a:picLocks noChangeAspect="1"/>
           </p:cNvPicPr>
@@ -18739,6 +18495,132 @@
         </p:blipFill>
         <p:spPr>
           <a:xfrm>
+            <a:off x="7360920" y="5029200"/>
+            <a:ext cx="914400" cy="914400"/>
+          </a:xfrm>
+          <a:prstGeom prst="rect">
+            <a:avLst/>
+          </a:prstGeom>
+        </p:spPr>
+      </p:pic>
+      <p:sp>
+        <p:nvSpPr>
+          <p:cNvPr id="52" name="Text 43"/>
+          <p:cNvSpPr txBox="1"/>
+          <p:nvPr/>
+        </p:nvSpPr>
+        <p:spPr>
+          <a:xfrm>
+            <a:off x="7178040" y="5971032"/>
+            <a:ext cx="1280160" cy="228600"/>
+          </a:xfrm>
+          <a:prstGeom prst="rect">
+            <a:avLst/>
+          </a:prstGeom>
+          <a:noFill/>
+          <a:ln/>
+        </p:spPr>
+        <p:txBody>
+          <a:bodyPr wrap="square" lIns="0" tIns="0" rIns="0" bIns="0" rtlCol="0" anchor="t"/>
+          <a:lstStyle/>
+          <a:p>
+            <a:pPr algn="ctr" indent="0" marL="0">
+              <a:buNone/>
+            </a:pPr>
+            <a:r>
+              <a:rPr lang="en-US" sz="1050" b="1" dirty="0">
+                <a:solidFill>
+                  <a:srgbClr val="FFFFFF"/>
+                </a:solidFill>
+                <a:latin typeface="Calibri" pitchFamily="34" charset="0"/>
+                <a:ea typeface="Calibri" pitchFamily="34" charset="-122"/>
+                <a:cs typeface="Calibri" pitchFamily="34" charset="-120"/>
+              </a:rPr>
+              <a:t>Demo video</a:t>
+            </a:r>
+            <a:endParaRPr lang="en-US" sz="1050" dirty="0"/>
+          </a:p>
+        </p:txBody>
+      </p:sp>
+      <p:pic>
+        <p:nvPicPr>
+          <p:cNvPr id="53" name="qr Live demo" descr="QR code: Live demo">    </p:cNvPr>
+          <p:cNvPicPr>
+            <a:picLocks noChangeAspect="1"/>
+          </p:cNvPicPr>
+          <p:nvPr/>
+        </p:nvPicPr>
+        <p:blipFill>
+          <a:blip r:embed="rId24"/>
+          <a:stretch>
+            <a:fillRect/>
+          </a:stretch>
+        </p:blipFill>
+        <p:spPr>
+          <a:xfrm>
+            <a:off x="8778240" y="5029200"/>
+            <a:ext cx="914400" cy="914400"/>
+          </a:xfrm>
+          <a:prstGeom prst="rect">
+            <a:avLst/>
+          </a:prstGeom>
+        </p:spPr>
+      </p:pic>
+      <p:sp>
+        <p:nvSpPr>
+          <p:cNvPr id="54" name="Text 44"/>
+          <p:cNvSpPr txBox="1"/>
+          <p:nvPr/>
+        </p:nvSpPr>
+        <p:spPr>
+          <a:xfrm>
+            <a:off x="8595360" y="5971032"/>
+            <a:ext cx="1280160" cy="228600"/>
+          </a:xfrm>
+          <a:prstGeom prst="rect">
+            <a:avLst/>
+          </a:prstGeom>
+          <a:noFill/>
+          <a:ln/>
+        </p:spPr>
+        <p:txBody>
+          <a:bodyPr wrap="square" lIns="0" tIns="0" rIns="0" bIns="0" rtlCol="0" anchor="t"/>
+          <a:lstStyle/>
+          <a:p>
+            <a:pPr algn="ctr" indent="0" marL="0">
+              <a:buNone/>
+            </a:pPr>
+            <a:r>
+              <a:rPr lang="en-US" sz="1050" b="1" dirty="0">
+                <a:solidFill>
+                  <a:srgbClr val="FFFFFF"/>
+                </a:solidFill>
+                <a:latin typeface="Calibri" pitchFamily="34" charset="0"/>
+                <a:ea typeface="Calibri" pitchFamily="34" charset="-122"/>
+                <a:cs typeface="Calibri" pitchFamily="34" charset="-120"/>
+              </a:rPr>
+              <a:t>Live demo</a:t>
+            </a:r>
+            <a:endParaRPr lang="en-US" sz="1050" dirty="0"/>
+          </a:p>
+        </p:txBody>
+      </p:sp>
+      <p:pic>
+        <p:nvPicPr>
+          <p:cNvPr id="55" name="qr GitHub" descr="QR code: GitHub">    </p:cNvPr>
+          <p:cNvPicPr>
+            <a:picLocks noChangeAspect="1"/>
+          </p:cNvPicPr>
+          <p:nvPr/>
+        </p:nvPicPr>
+        <p:blipFill>
+          <a:blip r:embed="rId25"/>
+          <a:stretch>
+            <a:fillRect/>
+          </a:stretch>
+        </p:blipFill>
+        <p:spPr>
+          <a:xfrm>
             <a:off x="10195560" y="5029200"/>
             <a:ext cx="914400" cy="914400"/>
           </a:xfrm>
@@ -18749,7 +18631,7 @@
       </p:pic>
       <p:sp>
         <p:nvSpPr>
-          <p:cNvPr id="54" name="Text 44"/>
+          <p:cNvPr id="56" name="Text 45"/>
           <p:cNvSpPr txBox="1"/>
           <p:nvPr/>
         </p:nvSpPr>

</xml_diff>